<commit_message>
Fix final-review findings: run commands, deck2 slide11 font, deck3 slide11 context, deck1 topic-2 pointer
- Deck 2 & 3: name the paired example file in AGENDA/first code slide,
  add a per-code-slide '실행: python examples/... --step N' caption
  (deck 1's slide-5 caption box is the style precedent).
- Deck 2 slide 11: two code panels were 7.5pt (below the series' 9pt
  floor) and dropped make_chat_node's actual return line; reworked to
  fix both.
- Deck 3 slide 11: the excel-tool code panel was a dangling indented
  fragment with no enclosing context; added a truncation caption and
  enclosing lines.
- Deck 1 (previously shipped): slide 12's next-topic teaser still
  promised the cancelled debug-logging topic; retargeted to the real
  topic 2 (프롬프트 입력 & LangChain vs LangGraph) and updated the
  eyebrow to '1편' to match the 2편/3편 convention.
</commit_message>
<xml_diff>
--- a/docs/교육자료/02_프롬프트와_LangGraph.pptx
+++ b/docs/교육자료/02_프롬프트와_LangGraph.pptx
@@ -16,6 +16,7 @@
     <p:sldId id="264" r:id="rId10"/>
     <p:sldId id="265" r:id="rId11"/>
     <p:sldId id="266" r:id="rId12"/>
+    <p:sldId id="269" r:id="rId20"/>
     <p:sldId id="267" r:id="rId13"/>
     <p:sldId id="268" r:id="rId14"/>
   </p:sldIdLst>
@@ -3794,7 +3795,7 @@
                 <a:ea typeface="Cambria" pitchFamily="34" charset="-122"/>
                 <a:cs typeface="Cambria" pitchFamily="34" charset="-120"/>
               </a:rPr>
-              <a:t>지금 배운 걸 그대로 쓰고 있다</a:t>
+              <a:t>지금 배운 걸 그대로 쓰고 있다 ①</a:t>
             </a:r>
             <a:endParaRPr lang="en-US" sz="3200" dirty="0"/>
           </a:p>
@@ -3809,7 +3810,7 @@
         <p:spPr>
           <a:xfrm>
             <a:off x="640080" y="1463040"/>
-            <a:ext cx="5943600" cy="4480560"/>
+            <a:ext cx="10911535" cy="4480560"/>
           </a:xfrm>
           <a:prstGeom prst="roundRect">
             <a:avLst>
@@ -3918,7 +3919,7 @@
         <p:spPr>
           <a:xfrm>
             <a:off x="896112" y="1847088"/>
-            <a:ext cx="5431536" cy="3950208"/>
+            <a:ext cx="10399471" cy="3950208"/>
           </a:xfrm>
           <a:prstGeom prst="rect">
             <a:avLst/>
@@ -6712,7 +6713,7 @@
         <p:spPr>
           <a:xfrm>
             <a:off x="640080" y="5998464"/>
-            <a:ext cx="5943600" cy="274320"/>
+            <a:ext cx="10911535" cy="274320"/>
           </a:xfrm>
           <a:prstGeom prst="rect">
             <a:avLst/>
@@ -6744,14 +6745,202 @@
       </p:sp>
       <p:sp>
         <p:nvSpPr>
+          <p:cNvPr id="22" name="Text 20"/>
+          <p:cNvSpPr/>
+          <p:nvPr/>
+        </p:nvSpPr>
+        <p:spPr>
+          <a:xfrm>
+            <a:off x="640080" y="6446520"/>
+            <a:ext cx="7315200" cy="274320"/>
+          </a:xfrm>
+          <a:prstGeom prst="rect">
+            <a:avLst/>
+          </a:prstGeom>
+          <a:noFill/>
+          <a:ln/>
+        </p:spPr>
+        <p:txBody>
+          <a:bodyPr wrap="square" lIns="0" tIns="0" rIns="0" bIns="0" rtlCol="0" anchor="ctr"/>
+          <a:lstStyle/>
+          <a:p>
+            <a:pPr indent="0" marL="0">
+              <a:buNone/>
+            </a:pPr>
+            <a:r>
+              <a:rPr lang="en-US" sz="900" dirty="0">
+                <a:solidFill>
+                  <a:srgbClr val="5F7075"/>
+                </a:solidFill>
+                <a:latin typeface="Calibri" pitchFamily="34" charset="0"/>
+                <a:ea typeface="Calibri" pitchFamily="34" charset="-122"/>
+                <a:cs typeface="Calibri" pitchFamily="34" charset="-120"/>
+              </a:rPr>
+              <a:t>프롬프트 &amp; LangGraph</a:t>
+            </a:r>
+            <a:endParaRPr lang="en-US" sz="900" dirty="0"/>
+          </a:p>
+        </p:txBody>
+      </p:sp>
+      <p:sp>
+        <p:nvSpPr>
+          <p:cNvPr id="23" name="Text 21"/>
+          <p:cNvSpPr/>
+          <p:nvPr/>
+        </p:nvSpPr>
+        <p:spPr>
+          <a:xfrm>
+            <a:off x="11094415" y="6446520"/>
+            <a:ext cx="457200" cy="274320"/>
+          </a:xfrm>
+          <a:prstGeom prst="rect">
+            <a:avLst/>
+          </a:prstGeom>
+          <a:noFill/>
+          <a:ln/>
+        </p:spPr>
+        <p:txBody>
+          <a:bodyPr wrap="square" lIns="0" tIns="0" rIns="0" bIns="0" rtlCol="0" anchor="ctr"/>
+          <a:lstStyle/>
+          <a:p>
+            <a:pPr algn="r" indent="0" marL="0">
+              <a:buNone/>
+            </a:pPr>
+            <a:r>
+              <a:rPr lang="en-US" sz="900" dirty="0">
+                <a:solidFill>
+                  <a:srgbClr val="5F7075"/>
+                </a:solidFill>
+                <a:latin typeface="Calibri" pitchFamily="34" charset="0"/>
+                <a:ea typeface="Calibri" pitchFamily="34" charset="-122"/>
+                <a:cs typeface="Calibri" pitchFamily="34" charset="-120"/>
+              </a:rPr>
+              <a:t>10</a:t>
+            </a:r>
+            <a:endParaRPr lang="en-US" sz="900" dirty="0"/>
+          </a:p>
+        </p:txBody>
+      </p:sp>
+    </p:spTree>
+  </p:cSld>
+  <p:clrMapOvr>
+    <a:masterClrMapping/>
+  </p:clrMapOvr>
+</p:sld>
+</file>
+
+<file path=ppt/slides/slide12.xml><?xml version="1.0" encoding="utf-8"?>
+<p:sld xmlns:a="http://schemas.openxmlformats.org/drawingml/2006/main" xmlns:r="http://schemas.openxmlformats.org/officeDocument/2006/relationships" xmlns:p="http://schemas.openxmlformats.org/presentationml/2006/main">
+  <p:cSld name="Slide 11">
+    <p:bg>
+      <p:bgPr>
+        <a:solidFill>
+          <a:srgbClr val="FFFFFF"/>
+        </a:solidFill>
+      </p:bgPr>
+    </p:bg>
+    <p:spTree>
+      <p:nvGrpSpPr>
+        <p:cNvPr id="1" name=""/>
+        <p:cNvGrpSpPr/>
+        <p:nvPr/>
+      </p:nvGrpSpPr>
+      <p:grpSpPr>
+        <a:xfrm>
+          <a:off x="0" y="0"/>
+          <a:ext cx="0" cy="0"/>
+          <a:chOff x="0" y="0"/>
+          <a:chExt cx="0" cy="0"/>
+        </a:xfrm>
+      </p:grpSpPr>
+      <p:sp>
+        <p:nvSpPr>
+          <p:cNvPr id="2" name="Text 0"/>
+          <p:cNvSpPr/>
+          <p:nvPr/>
+        </p:nvSpPr>
+        <p:spPr>
+          <a:xfrm>
+            <a:off x="640080" y="384048"/>
+            <a:ext cx="10911535" cy="274320"/>
+          </a:xfrm>
+          <a:prstGeom prst="rect">
+            <a:avLst/>
+          </a:prstGeom>
+          <a:noFill/>
+          <a:ln/>
+        </p:spPr>
+        <p:txBody>
+          <a:bodyPr wrap="square" lIns="0" tIns="0" rIns="0" bIns="0" rtlCol="0" anchor="ctr"/>
+          <a:lstStyle/>
+          <a:p>
+            <a:pPr indent="0" marL="0">
+              <a:buNone/>
+            </a:pPr>
+            <a:r>
+              <a:rPr lang="en-US" sz="1200" b="1" spc="200" kern="0" dirty="0">
+                <a:solidFill>
+                  <a:srgbClr val="028090"/>
+                </a:solidFill>
+                <a:latin typeface="Calibri" pitchFamily="34" charset="0"/>
+                <a:ea typeface="Calibri" pitchFamily="34" charset="-122"/>
+                <a:cs typeface="Calibri" pitchFamily="34" charset="-120"/>
+              </a:rPr>
+              <a:t>우리 앱은 이렇게</a:t>
+            </a:r>
+            <a:endParaRPr lang="en-US" sz="1200" dirty="0"/>
+          </a:p>
+        </p:txBody>
+      </p:sp>
+      <p:sp>
+        <p:nvSpPr>
+          <p:cNvPr id="3" name="Text 1"/>
+          <p:cNvSpPr/>
+          <p:nvPr/>
+        </p:nvSpPr>
+        <p:spPr>
+          <a:xfrm>
+            <a:off x="640080" y="658368"/>
+            <a:ext cx="10911535" cy="640080"/>
+          </a:xfrm>
+          <a:prstGeom prst="rect">
+            <a:avLst/>
+          </a:prstGeom>
+          <a:noFill/>
+          <a:ln/>
+        </p:spPr>
+        <p:txBody>
+          <a:bodyPr wrap="square" lIns="0" tIns="0" rIns="0" bIns="0" rtlCol="0" anchor="ctr"/>
+          <a:lstStyle/>
+          <a:p>
+            <a:pPr indent="0" marL="0">
+              <a:buNone/>
+            </a:pPr>
+            <a:r>
+              <a:rPr lang="en-US" sz="3200" b="1" dirty="0">
+                <a:solidFill>
+                  <a:srgbClr val="17282C"/>
+                </a:solidFill>
+                <a:latin typeface="Cambria" pitchFamily="34" charset="0"/>
+                <a:ea typeface="Cambria" pitchFamily="34" charset="-122"/>
+                <a:cs typeface="Cambria" pitchFamily="34" charset="-120"/>
+              </a:rPr>
+              <a:t>지금 배운 걸 그대로 쓰고 있다 ②</a:t>
+            </a:r>
+            <a:endParaRPr lang="en-US" sz="3200" dirty="0"/>
+          </a:p>
+        </p:txBody>
+      </p:sp>
+      <p:sp>
+        <p:nvSpPr>
           <p:cNvPr id="10" name="Shape 8"/>
           <p:cNvSpPr/>
           <p:nvPr/>
         </p:nvSpPr>
         <p:spPr>
           <a:xfrm>
-            <a:off x="6876288" y="1463040"/>
-            <a:ext cx="4675327" cy="1874520"/>
+            <a:off x="640080" y="1463040"/>
+            <a:ext cx="5609232" cy="4480560"/>
           </a:xfrm>
           <a:prstGeom prst="roundRect">
             <a:avLst>
@@ -6784,7 +6973,7 @@
         </p:nvSpPr>
         <p:spPr>
           <a:xfrm>
-            <a:off x="7077456" y="1645920"/>
+            <a:off x="841248" y="1645920"/>
             <a:ext cx="100584" cy="100584"/>
           </a:xfrm>
           <a:prstGeom prst="ellipse">
@@ -6809,7 +6998,7 @@
         </p:nvSpPr>
         <p:spPr>
           <a:xfrm>
-            <a:off x="7278624" y="1645920"/>
+            <a:off x="1042416" y="1645920"/>
             <a:ext cx="100584" cy="100584"/>
           </a:xfrm>
           <a:prstGeom prst="ellipse">
@@ -6834,7 +7023,7 @@
         </p:nvSpPr>
         <p:spPr>
           <a:xfrm>
-            <a:off x="7479792" y="1645920"/>
+            <a:off x="1243584" y="1645920"/>
             <a:ext cx="100584" cy="100584"/>
           </a:xfrm>
           <a:prstGeom prst="ellipse">
@@ -6859,8 +7048,8 @@
         </p:nvSpPr>
         <p:spPr>
           <a:xfrm>
-            <a:off x="7132320" y="1847088"/>
-            <a:ext cx="4163263" cy="1344168"/>
+            <a:off x="896112" y="1847088"/>
+            <a:ext cx="5097168" cy="3950208"/>
           </a:xfrm>
           <a:prstGeom prst="rect">
             <a:avLst/>
@@ -6879,7 +7068,7 @@
               <a:buNone/>
             </a:pPr>
             <a:r>
-              <a:rPr lang="en-US" sz="750" dirty="0">
+              <a:rPr lang="en-US" sz="900" dirty="0">
                 <a:solidFill>
                   <a:srgbClr val="569CD6"/>
                 </a:solidFill>
@@ -6896,7 +7085,7 @@
               <a:buNone/>
             </a:pPr>
             <a:r>
-              <a:rPr lang="en-US" sz="750" dirty="0">
+              <a:rPr lang="en-US" sz="900" dirty="0">
                 <a:solidFill>
                   <a:srgbClr val="D4D4D4"/>
                 </a:solidFill>
@@ -6913,7 +7102,7 @@
               <a:buNone/>
             </a:pPr>
             <a:r>
-              <a:rPr lang="en-US" sz="750" dirty="0">
+              <a:rPr lang="en-US" sz="900" dirty="0">
                 <a:solidFill>
                   <a:srgbClr val="DCDCAA"/>
                 </a:solidFill>
@@ -6930,7 +7119,7 @@
               <a:buNone/>
             </a:pPr>
             <a:r>
-              <a:rPr lang="en-US" sz="750" dirty="0">
+              <a:rPr lang="en-US" sz="900" dirty="0">
                 <a:solidFill>
                   <a:srgbClr val="D4D4D4"/>
                 </a:solidFill>
@@ -6947,7 +7136,7 @@
               <a:buNone/>
             </a:pPr>
             <a:r>
-              <a:rPr lang="en-US" sz="750" dirty="0">
+              <a:rPr lang="en-US" sz="900" dirty="0">
                 <a:solidFill>
                   <a:srgbClr val="D4D4D4"/>
                 </a:solidFill>
@@ -6964,7 +7153,7 @@
               <a:buNone/>
             </a:pPr>
             <a:r>
-              <a:rPr lang="en-US" sz="750" dirty="0">
+              <a:rPr lang="en-US" sz="900" dirty="0">
                 <a:solidFill>
                   <a:srgbClr val="D4D4D4"/>
                 </a:solidFill>
@@ -6981,7 +7170,7 @@
               <a:buNone/>
             </a:pPr>
             <a:r>
-              <a:rPr lang="en-US" sz="750" dirty="0">
+              <a:rPr lang="en-US" sz="900" dirty="0">
                 <a:solidFill>
                   <a:srgbClr val="D4D4D4"/>
                 </a:solidFill>
@@ -6998,7 +7187,7 @@
               <a:buNone/>
             </a:pPr>
             <a:r>
-              <a:rPr lang="en-US" sz="750" dirty="0">
+              <a:rPr lang="en-US" sz="900" dirty="0">
                 <a:solidFill>
                   <a:srgbClr val="D4D4D4"/>
                 </a:solidFill>
@@ -7015,7 +7204,7 @@
               <a:buNone/>
             </a:pPr>
             <a:r>
-              <a:rPr lang="en-US" sz="750" dirty="0">
+              <a:rPr lang="en-US" sz="900" dirty="0">
                 <a:solidFill>
                   <a:srgbClr val="D4D4D4"/>
                 </a:solidFill>
@@ -7032,7 +7221,7 @@
               <a:buNone/>
             </a:pPr>
             <a:r>
-              <a:rPr lang="en-US" sz="750" dirty="0">
+              <a:rPr lang="en-US" sz="900" dirty="0">
                 <a:solidFill>
                   <a:srgbClr val="D4D4D4"/>
                 </a:solidFill>
@@ -7052,7 +7241,7 @@
               <a:buNone/>
             </a:pPr>
             <a:r>
-              <a:rPr lang="en-US" sz="750" dirty="0">
+              <a:rPr lang="en-US" sz="900" dirty="0">
                 <a:solidFill>
                   <a:srgbClr val="D4D4D4"/>
                 </a:solidFill>
@@ -7069,7 +7258,7 @@
               <a:buNone/>
             </a:pPr>
             <a:r>
-              <a:rPr lang="en-US" sz="750" dirty="0">
+              <a:rPr lang="en-US" sz="900" dirty="0">
                 <a:solidFill>
                   <a:srgbClr val="569CD6"/>
                 </a:solidFill>
@@ -7086,7 +7275,7 @@
               <a:buNone/>
             </a:pPr>
             <a:r>
-              <a:rPr lang="en-US" sz="750" dirty="0">
+              <a:rPr lang="en-US" sz="900" dirty="0">
                 <a:solidFill>
                   <a:srgbClr val="D4D4D4"/>
                 </a:solidFill>
@@ -7103,7 +7292,7 @@
               <a:buNone/>
             </a:pPr>
             <a:r>
-              <a:rPr lang="en-US" sz="750" dirty="0">
+              <a:rPr lang="en-US" sz="900" dirty="0">
                 <a:solidFill>
                   <a:srgbClr val="569CD6"/>
                 </a:solidFill>
@@ -7120,7 +7309,7 @@
               <a:buNone/>
             </a:pPr>
             <a:r>
-              <a:rPr lang="en-US" sz="750" dirty="0">
+              <a:rPr lang="en-US" sz="900" dirty="0">
                 <a:solidFill>
                   <a:srgbClr val="D4D4D4"/>
                 </a:solidFill>
@@ -7137,7 +7326,7 @@
               <a:buNone/>
             </a:pPr>
             <a:r>
-              <a:rPr lang="en-US" sz="750" dirty="0">
+              <a:rPr lang="en-US" sz="900" dirty="0">
                 <a:solidFill>
                   <a:srgbClr val="DCDCAA"/>
                 </a:solidFill>
@@ -7154,7 +7343,7 @@
               <a:buNone/>
             </a:pPr>
             <a:r>
-              <a:rPr lang="en-US" sz="750" dirty="0">
+              <a:rPr lang="en-US" sz="900" dirty="0">
                 <a:solidFill>
                   <a:srgbClr val="D4D4D4"/>
                 </a:solidFill>
@@ -7171,7 +7360,7 @@
               <a:buNone/>
             </a:pPr>
             <a:r>
-              <a:rPr lang="en-US" sz="750" dirty="0">
+              <a:rPr lang="en-US" sz="900" dirty="0">
                 <a:solidFill>
                   <a:srgbClr val="D4D4D4"/>
                 </a:solidFill>
@@ -7188,7 +7377,7 @@
               <a:buNone/>
             </a:pPr>
             <a:r>
-              <a:rPr lang="en-US" sz="750" dirty="0">
+              <a:rPr lang="en-US" sz="900" dirty="0">
                 <a:solidFill>
                   <a:srgbClr val="D4D4D4"/>
                 </a:solidFill>
@@ -7205,7 +7394,7 @@
               <a:buNone/>
             </a:pPr>
             <a:r>
-              <a:rPr lang="en-US" sz="750" dirty="0">
+              <a:rPr lang="en-US" sz="900" dirty="0">
                 <a:solidFill>
                   <a:srgbClr val="D4D4D4"/>
                 </a:solidFill>
@@ -7222,7 +7411,7 @@
               <a:buNone/>
             </a:pPr>
             <a:r>
-              <a:rPr lang="en-US" sz="750" dirty="0">
+              <a:rPr lang="en-US" sz="900" dirty="0">
                 <a:solidFill>
                   <a:srgbClr val="D4D4D4"/>
                 </a:solidFill>
@@ -7239,7 +7428,7 @@
               <a:buNone/>
             </a:pPr>
             <a:r>
-              <a:rPr lang="en-US" sz="750" dirty="0">
+              <a:rPr lang="en-US" sz="900" dirty="0">
                 <a:solidFill>
                   <a:srgbClr val="D4D4D4"/>
                 </a:solidFill>
@@ -7256,7 +7445,7 @@
               <a:buNone/>
             </a:pPr>
             <a:r>
-              <a:rPr lang="en-US" sz="750" dirty="0">
+              <a:rPr lang="en-US" sz="900" dirty="0">
                 <a:solidFill>
                   <a:srgbClr val="D4D4D4"/>
                 </a:solidFill>
@@ -7276,7 +7465,7 @@
               <a:buNone/>
             </a:pPr>
             <a:r>
-              <a:rPr lang="en-US" sz="750" dirty="0">
+              <a:rPr lang="en-US" sz="900" dirty="0">
                 <a:solidFill>
                   <a:srgbClr val="D4D4D4"/>
                 </a:solidFill>
@@ -7293,7 +7482,7 @@
               <a:buNone/>
             </a:pPr>
             <a:r>
-              <a:rPr lang="en-US" sz="750" dirty="0">
+              <a:rPr lang="en-US" sz="900" dirty="0">
                 <a:solidFill>
                   <a:srgbClr val="6A9955"/>
                 </a:solidFill>
@@ -7313,7 +7502,7 @@
               <a:buNone/>
             </a:pPr>
             <a:r>
-              <a:rPr lang="en-US" sz="750" dirty="0">
+              <a:rPr lang="en-US" sz="900" dirty="0">
                 <a:solidFill>
                   <a:srgbClr val="D4D4D4"/>
                 </a:solidFill>
@@ -7330,7 +7519,7 @@
               <a:buNone/>
             </a:pPr>
             <a:r>
-              <a:rPr lang="en-US" sz="750" dirty="0">
+              <a:rPr lang="en-US" sz="900" dirty="0">
                 <a:solidFill>
                   <a:srgbClr val="6A9955"/>
                 </a:solidFill>
@@ -7350,7 +7539,7 @@
               <a:buNone/>
             </a:pPr>
             <a:r>
-              <a:rPr lang="en-US" sz="750" dirty="0">
+              <a:rPr lang="en-US" sz="900" dirty="0">
                 <a:solidFill>
                   <a:srgbClr val="D4D4D4"/>
                 </a:solidFill>
@@ -7367,7 +7556,7 @@
               <a:buNone/>
             </a:pPr>
             <a:r>
-              <a:rPr lang="en-US" sz="750" dirty="0">
+              <a:rPr lang="en-US" sz="900" dirty="0">
                 <a:solidFill>
                   <a:srgbClr val="D4D4D4"/>
                 </a:solidFill>
@@ -7384,7 +7573,7 @@
               <a:buNone/>
             </a:pPr>
             <a:r>
-              <a:rPr lang="en-US" sz="750" dirty="0">
+              <a:rPr lang="en-US" sz="900" dirty="0">
                 <a:solidFill>
                   <a:srgbClr val="D4D4D4"/>
                 </a:solidFill>
@@ -7401,7 +7590,7 @@
               <a:buNone/>
             </a:pPr>
             <a:r>
-              <a:rPr lang="en-US" sz="750" dirty="0">
+              <a:rPr lang="en-US" sz="900" dirty="0">
                 <a:solidFill>
                   <a:srgbClr val="DCDCAA"/>
                 </a:solidFill>
@@ -7418,7 +7607,7 @@
               <a:buNone/>
             </a:pPr>
             <a:r>
-              <a:rPr lang="en-US" sz="750" dirty="0">
+              <a:rPr lang="en-US" sz="900" dirty="0">
                 <a:solidFill>
                   <a:srgbClr val="D4D4D4"/>
                 </a:solidFill>
@@ -7435,7 +7624,7 @@
               <a:buNone/>
             </a:pPr>
             <a:r>
-              <a:rPr lang="en-US" sz="750" dirty="0">
+              <a:rPr lang="en-US" sz="900" dirty="0">
                 <a:solidFill>
                   <a:srgbClr val="D4D4D4"/>
                 </a:solidFill>
@@ -7452,7 +7641,7 @@
               <a:buNone/>
             </a:pPr>
             <a:r>
-              <a:rPr lang="en-US" sz="750" dirty="0">
+              <a:rPr lang="en-US" sz="900" dirty="0">
                 <a:solidFill>
                   <a:srgbClr val="D4D4D4"/>
                 </a:solidFill>
@@ -7469,7 +7658,7 @@
               <a:buNone/>
             </a:pPr>
             <a:r>
-              <a:rPr lang="en-US" sz="750" dirty="0">
+              <a:rPr lang="en-US" sz="900" dirty="0">
                 <a:solidFill>
                   <a:srgbClr val="D4D4D4"/>
                 </a:solidFill>
@@ -7486,7 +7675,7 @@
               <a:buNone/>
             </a:pPr>
             <a:r>
-              <a:rPr lang="en-US" sz="750" dirty="0">
+              <a:rPr lang="en-US" sz="900" dirty="0">
                 <a:solidFill>
                   <a:srgbClr val="D4D4D4"/>
                 </a:solidFill>
@@ -7506,7 +7695,7 @@
               <a:buNone/>
             </a:pPr>
             <a:r>
-              <a:rPr lang="en-US" sz="750" dirty="0">
+              <a:rPr lang="en-US" sz="900" dirty="0">
                 <a:solidFill>
                   <a:srgbClr val="D4D4D4"/>
                 </a:solidFill>
@@ -7523,7 +7712,7 @@
               <a:buNone/>
             </a:pPr>
             <a:r>
-              <a:rPr lang="en-US" sz="750" dirty="0">
+              <a:rPr lang="en-US" sz="900" dirty="0">
                 <a:solidFill>
                   <a:srgbClr val="D4D4D4"/>
                 </a:solidFill>
@@ -7540,7 +7729,7 @@
               <a:buNone/>
             </a:pPr>
             <a:r>
-              <a:rPr lang="en-US" sz="750" dirty="0">
+              <a:rPr lang="en-US" sz="900" dirty="0">
                 <a:solidFill>
                   <a:srgbClr val="D4D4D4"/>
                 </a:solidFill>
@@ -7557,7 +7746,7 @@
               <a:buNone/>
             </a:pPr>
             <a:r>
-              <a:rPr lang="en-US" sz="750" dirty="0">
+              <a:rPr lang="en-US" sz="900" dirty="0">
                 <a:solidFill>
                   <a:srgbClr val="CE9178"/>
                 </a:solidFill>
@@ -7574,7 +7763,7 @@
               <a:buNone/>
             </a:pPr>
             <a:r>
-              <a:rPr lang="en-US" sz="750" dirty="0">
+              <a:rPr lang="en-US" sz="900" dirty="0">
                 <a:solidFill>
                   <a:srgbClr val="D4D4D4"/>
                 </a:solidFill>
@@ -7594,7 +7783,7 @@
               <a:buNone/>
             </a:pPr>
             <a:r>
-              <a:rPr lang="en-US" sz="750" dirty="0">
+              <a:rPr lang="en-US" sz="900" dirty="0">
                 <a:solidFill>
                   <a:srgbClr val="D4D4D4"/>
                 </a:solidFill>
@@ -7611,7 +7800,7 @@
               <a:buNone/>
             </a:pPr>
             <a:r>
-              <a:rPr lang="en-US" sz="750" dirty="0">
+              <a:rPr lang="en-US" sz="900" dirty="0">
                 <a:solidFill>
                   <a:srgbClr val="D4D4D4"/>
                 </a:solidFill>
@@ -7628,7 +7817,7 @@
               <a:buNone/>
             </a:pPr>
             <a:r>
-              <a:rPr lang="en-US" sz="750" dirty="0">
+              <a:rPr lang="en-US" sz="900" dirty="0">
                 <a:solidFill>
                   <a:srgbClr val="D4D4D4"/>
                 </a:solidFill>
@@ -7645,7 +7834,7 @@
               <a:buNone/>
             </a:pPr>
             <a:r>
-              <a:rPr lang="en-US" sz="750" dirty="0">
+              <a:rPr lang="en-US" sz="900" dirty="0">
                 <a:solidFill>
                   <a:srgbClr val="569CD6"/>
                 </a:solidFill>
@@ -7662,7 +7851,7 @@
               <a:buNone/>
             </a:pPr>
             <a:r>
-              <a:rPr lang="en-US" sz="750" dirty="0">
+              <a:rPr lang="en-US" sz="900" dirty="0">
                 <a:solidFill>
                   <a:srgbClr val="D4D4D4"/>
                 </a:solidFill>
@@ -7679,7 +7868,7 @@
               <a:buNone/>
             </a:pPr>
             <a:r>
-              <a:rPr lang="en-US" sz="750" dirty="0">
+              <a:rPr lang="en-US" sz="900" dirty="0">
                 <a:solidFill>
                   <a:srgbClr val="D4D4D4"/>
                 </a:solidFill>
@@ -7696,7 +7885,7 @@
               <a:buNone/>
             </a:pPr>
             <a:r>
-              <a:rPr lang="en-US" sz="750" dirty="0">
+              <a:rPr lang="en-US" sz="900" dirty="0">
                 <a:solidFill>
                   <a:srgbClr val="D4D4D4"/>
                 </a:solidFill>
@@ -7713,7 +7902,7 @@
               <a:buNone/>
             </a:pPr>
             <a:r>
-              <a:rPr lang="en-US" sz="750" dirty="0">
+              <a:rPr lang="en-US" sz="900" dirty="0">
                 <a:solidFill>
                   <a:srgbClr val="DCDCAA"/>
                 </a:solidFill>
@@ -7730,7 +7919,7 @@
               <a:buNone/>
             </a:pPr>
             <a:r>
-              <a:rPr lang="en-US" sz="750" dirty="0">
+              <a:rPr lang="en-US" sz="900" dirty="0">
                 <a:solidFill>
                   <a:srgbClr val="D4D4D4"/>
                 </a:solidFill>
@@ -7747,7 +7936,7 @@
               <a:buNone/>
             </a:pPr>
             <a:r>
-              <a:rPr lang="en-US" sz="750" dirty="0">
+              <a:rPr lang="en-US" sz="900" dirty="0">
                 <a:solidFill>
                   <a:srgbClr val="D4D4D4"/>
                 </a:solidFill>
@@ -7764,7 +7953,7 @@
               <a:buNone/>
             </a:pPr>
             <a:r>
-              <a:rPr lang="en-US" sz="750" dirty="0">
+              <a:rPr lang="en-US" sz="900" dirty="0">
                 <a:solidFill>
                   <a:srgbClr val="D4D4D4"/>
                 </a:solidFill>
@@ -7784,7 +7973,7 @@
               <a:buNone/>
             </a:pPr>
             <a:r>
-              <a:rPr lang="en-US" sz="750" dirty="0">
+              <a:rPr lang="en-US" sz="900" dirty="0">
                 <a:solidFill>
                   <a:srgbClr val="D4D4D4"/>
                 </a:solidFill>
@@ -7801,7 +7990,7 @@
               <a:buNone/>
             </a:pPr>
             <a:r>
-              <a:rPr lang="en-US" sz="750" dirty="0">
+              <a:rPr lang="en-US" sz="900" dirty="0">
                 <a:solidFill>
                   <a:srgbClr val="569CD6"/>
                 </a:solidFill>
@@ -7818,7 +8007,7 @@
               <a:buNone/>
             </a:pPr>
             <a:r>
-              <a:rPr lang="en-US" sz="750" dirty="0">
+              <a:rPr lang="en-US" sz="900" dirty="0">
                 <a:solidFill>
                   <a:srgbClr val="D4D4D4"/>
                 </a:solidFill>
@@ -7835,7 +8024,7 @@
               <a:buNone/>
             </a:pPr>
             <a:r>
-              <a:rPr lang="en-US" sz="750" dirty="0">
+              <a:rPr lang="en-US" sz="900" dirty="0">
                 <a:solidFill>
                   <a:srgbClr val="CE9178"/>
                 </a:solidFill>
@@ -7852,7 +8041,7 @@
               <a:buNone/>
             </a:pPr>
             <a:r>
-              <a:rPr lang="en-US" sz="750" dirty="0">
+              <a:rPr lang="en-US" sz="900" dirty="0">
                 <a:solidFill>
                   <a:srgbClr val="D4D4D4"/>
                 </a:solidFill>
@@ -7869,7 +8058,7 @@
               <a:buNone/>
             </a:pPr>
             <a:r>
-              <a:rPr lang="en-US" sz="750" dirty="0">
+              <a:rPr lang="en-US" sz="900" dirty="0">
                 <a:solidFill>
                   <a:srgbClr val="D4D4D4"/>
                 </a:solidFill>
@@ -7886,7 +8075,7 @@
               <a:buNone/>
             </a:pPr>
             <a:r>
-              <a:rPr lang="en-US" sz="750" dirty="0">
+              <a:rPr lang="en-US" sz="900" dirty="0">
                 <a:solidFill>
                   <a:srgbClr val="D4D4D4"/>
                 </a:solidFill>
@@ -7898,6 +8087,80 @@
             </a:r>
             <a:endParaRPr lang="en-US" sz="750" dirty="0"/>
           </a:p>
+          <a:p>
+            <a:pPr algn="l" indent="0" marL="0">
+              <a:lnSpc>
+                <a:spcPct val="108000"/>
+              </a:lnSpc>
+              <a:buNone/>
+            </a:pPr>
+            <a:r>
+              <a:rPr lang="en-US" sz="900" dirty="0">
+                <a:solidFill>
+                  <a:srgbClr val="D4D4D4"/>
+                </a:solidFill>
+                <a:latin typeface="Courier New" pitchFamily="34" charset="0"/>
+                <a:ea typeface="Courier New" pitchFamily="34" charset="-122"/>
+                <a:cs typeface="Courier New" pitchFamily="34" charset="-120"/>
+              </a:rPr>
+              <a:t> </a:t>
+            </a:r>
+            <a:endParaRPr lang="en-US" sz="750" dirty="0"/>
+          </a:p>
+          <a:p>
+            <a:pPr algn="l" indent="0" marL="0">
+              <a:lnSpc>
+                <a:spcPct val="108000"/>
+              </a:lnSpc>
+              <a:buNone/>
+            </a:pPr>
+            <a:r>
+              <a:rPr lang="en-US" sz="900" dirty="0">
+                <a:solidFill>
+                  <a:srgbClr val="D4D4D4"/>
+                </a:solidFill>
+                <a:latin typeface="Courier New" pitchFamily="34" charset="0"/>
+                <a:ea typeface="Courier New" pitchFamily="34" charset="-122"/>
+                <a:cs typeface="Courier New" pitchFamily="34" charset="-120"/>
+              </a:rPr>
+              <a:t>    </a:t>
+            </a:r>
+            <a:pPr algn="l" indent="0" marL="0">
+              <a:lnSpc>
+                <a:spcPct val="108000"/>
+              </a:lnSpc>
+              <a:buNone/>
+            </a:pPr>
+            <a:r>
+              <a:rPr lang="en-US" sz="900" dirty="0">
+                <a:solidFill>
+                  <a:srgbClr val="569CD6"/>
+                </a:solidFill>
+                <a:latin typeface="Courier New" pitchFamily="34" charset="0"/>
+                <a:ea typeface="Courier New" pitchFamily="34" charset="-122"/>
+                <a:cs typeface="Courier New" pitchFamily="34" charset="-120"/>
+              </a:rPr>
+              <a:t>return</a:t>
+            </a:r>
+            <a:pPr algn="l" indent="0" marL="0">
+              <a:lnSpc>
+                <a:spcPct val="108000"/>
+              </a:lnSpc>
+              <a:buNone/>
+            </a:pPr>
+            <a:r>
+              <a:rPr lang="en-US" sz="900" dirty="0">
+                <a:solidFill>
+                  <a:srgbClr val="D4D4D4"/>
+                </a:solidFill>
+                <a:latin typeface="Courier New" pitchFamily="34" charset="0"/>
+                <a:ea typeface="Courier New" pitchFamily="34" charset="-122"/>
+                <a:cs typeface="Courier New" pitchFamily="34" charset="-120"/>
+              </a:rPr>
+              <a:t> chat_node</a:t>
+            </a:r>
+            <a:endParaRPr lang="en-US" sz="750" dirty="0"/>
+          </a:p>
         </p:txBody>
       </p:sp>
       <p:sp>
@@ -7908,8 +8171,8 @@
         </p:nvSpPr>
         <p:spPr>
           <a:xfrm>
-            <a:off x="6876288" y="3392424"/>
-            <a:ext cx="4675327" cy="274320"/>
+            <a:off x="640080" y="5998464"/>
+            <a:ext cx="5609232" cy="274320"/>
           </a:xfrm>
           <a:prstGeom prst="rect">
             <a:avLst/>
@@ -7947,8 +8210,8 @@
         </p:nvSpPr>
         <p:spPr>
           <a:xfrm>
-            <a:off x="6876288" y="3657600"/>
-            <a:ext cx="4675327" cy="2286000"/>
+            <a:off x="6541920" y="1463040"/>
+            <a:ext cx="5008600" cy="4480560"/>
           </a:xfrm>
           <a:prstGeom prst="roundRect">
             <a:avLst>
@@ -7981,7 +8244,7 @@
         </p:nvSpPr>
         <p:spPr>
           <a:xfrm>
-            <a:off x="7077456" y="3840480"/>
+            <a:off x="6743088" y="1645920"/>
             <a:ext cx="100584" cy="100584"/>
           </a:xfrm>
           <a:prstGeom prst="ellipse">
@@ -8006,7 +8269,7 @@
         </p:nvSpPr>
         <p:spPr>
           <a:xfrm>
-            <a:off x="7278624" y="3840480"/>
+            <a:off x="6944256" y="1645920"/>
             <a:ext cx="100584" cy="100584"/>
           </a:xfrm>
           <a:prstGeom prst="ellipse">
@@ -8031,7 +8294,7 @@
         </p:nvSpPr>
         <p:spPr>
           <a:xfrm>
-            <a:off x="7479792" y="3840480"/>
+            <a:off x="7145424" y="1645920"/>
             <a:ext cx="100584" cy="100584"/>
           </a:xfrm>
           <a:prstGeom prst="ellipse">
@@ -8056,8 +8319,8 @@
         </p:nvSpPr>
         <p:spPr>
           <a:xfrm>
-            <a:off x="7132320" y="4041648"/>
-            <a:ext cx="4163263" cy="1755648"/>
+            <a:off x="6797952" y="1847088"/>
+            <a:ext cx="4496536" cy="3950208"/>
           </a:xfrm>
           <a:prstGeom prst="rect">
             <a:avLst/>
@@ -8076,7 +8339,7 @@
               <a:buNone/>
             </a:pPr>
             <a:r>
-              <a:rPr lang="en-US" sz="750" dirty="0">
+              <a:rPr lang="en-US" sz="900" dirty="0">
                 <a:solidFill>
                   <a:srgbClr val="D4D4D4"/>
                 </a:solidFill>
@@ -8093,7 +8356,7 @@
               <a:buNone/>
             </a:pPr>
             <a:r>
-              <a:rPr lang="en-US" sz="750" dirty="0">
+              <a:rPr lang="en-US" sz="900" dirty="0">
                 <a:solidFill>
                   <a:srgbClr val="D4D4D4"/>
                 </a:solidFill>
@@ -8110,7 +8373,7 @@
               <a:buNone/>
             </a:pPr>
             <a:r>
-              <a:rPr lang="en-US" sz="750" dirty="0">
+              <a:rPr lang="en-US" sz="900" dirty="0">
                 <a:solidFill>
                   <a:srgbClr val="CE9178"/>
                 </a:solidFill>
@@ -8127,7 +8390,7 @@
               <a:buNone/>
             </a:pPr>
             <a:r>
-              <a:rPr lang="en-US" sz="750" dirty="0">
+              <a:rPr lang="en-US" sz="900" dirty="0">
                 <a:solidFill>
                   <a:srgbClr val="D4D4D4"/>
                 </a:solidFill>
@@ -8147,7 +8410,7 @@
               <a:buNone/>
             </a:pPr>
             <a:r>
-              <a:rPr lang="en-US" sz="750" dirty="0">
+              <a:rPr lang="en-US" sz="900" dirty="0">
                 <a:solidFill>
                   <a:srgbClr val="D4D4D4"/>
                 </a:solidFill>
@@ -8164,7 +8427,7 @@
               <a:buNone/>
             </a:pPr>
             <a:r>
-              <a:rPr lang="en-US" sz="750" dirty="0">
+              <a:rPr lang="en-US" sz="900" dirty="0">
                 <a:solidFill>
                   <a:srgbClr val="D4D4D4"/>
                 </a:solidFill>
@@ -8181,7 +8444,7 @@
               <a:buNone/>
             </a:pPr>
             <a:r>
-              <a:rPr lang="en-US" sz="750" dirty="0">
+              <a:rPr lang="en-US" sz="900" dirty="0">
                 <a:solidFill>
                   <a:srgbClr val="D4D4D4"/>
                 </a:solidFill>
@@ -8198,7 +8461,7 @@
               <a:buNone/>
             </a:pPr>
             <a:r>
-              <a:rPr lang="en-US" sz="750" dirty="0">
+              <a:rPr lang="en-US" sz="900" dirty="0">
                 <a:solidFill>
                   <a:srgbClr val="D4D4D4"/>
                 </a:solidFill>
@@ -8215,7 +8478,7 @@
               <a:buNone/>
             </a:pPr>
             <a:r>
-              <a:rPr lang="en-US" sz="750" dirty="0">
+              <a:rPr lang="en-US" sz="900" dirty="0">
                 <a:solidFill>
                   <a:srgbClr val="D4D4D4"/>
                 </a:solidFill>
@@ -8232,7 +8495,7 @@
               <a:buNone/>
             </a:pPr>
             <a:r>
-              <a:rPr lang="en-US" sz="750" dirty="0">
+              <a:rPr lang="en-US" sz="900" dirty="0">
                 <a:solidFill>
                   <a:srgbClr val="D4D4D4"/>
                 </a:solidFill>
@@ -8252,7 +8515,7 @@
               <a:buNone/>
             </a:pPr>
             <a:r>
-              <a:rPr lang="en-US" sz="750" dirty="0">
+              <a:rPr lang="en-US" sz="900" dirty="0">
                 <a:solidFill>
                   <a:srgbClr val="D4D4D4"/>
                 </a:solidFill>
@@ -8269,7 +8532,7 @@
               <a:buNone/>
             </a:pPr>
             <a:r>
-              <a:rPr lang="en-US" sz="750" dirty="0">
+              <a:rPr lang="en-US" sz="900" dirty="0">
                 <a:solidFill>
                   <a:srgbClr val="D4D4D4"/>
                 </a:solidFill>
@@ -8289,7 +8552,7 @@
               <a:buNone/>
             </a:pPr>
             <a:r>
-              <a:rPr lang="en-US" sz="750" dirty="0">
+              <a:rPr lang="en-US" sz="900" dirty="0">
                 <a:solidFill>
                   <a:srgbClr val="D4D4D4"/>
                 </a:solidFill>
@@ -8309,7 +8572,7 @@
               <a:buNone/>
             </a:pPr>
             <a:r>
-              <a:rPr lang="en-US" sz="750" dirty="0">
+              <a:rPr lang="en-US" sz="900" dirty="0">
                 <a:solidFill>
                   <a:srgbClr val="D4D4D4"/>
                 </a:solidFill>
@@ -8329,7 +8592,7 @@
               <a:buNone/>
             </a:pPr>
             <a:r>
-              <a:rPr lang="en-US" sz="750" dirty="0">
+              <a:rPr lang="en-US" sz="900" dirty="0">
                 <a:solidFill>
                   <a:srgbClr val="D4D4D4"/>
                 </a:solidFill>
@@ -8349,7 +8612,7 @@
               <a:buNone/>
             </a:pPr>
             <a:r>
-              <a:rPr lang="en-US" sz="750" dirty="0">
+              <a:rPr lang="en-US" sz="900" dirty="0">
                 <a:solidFill>
                   <a:srgbClr val="D4D4D4"/>
                 </a:solidFill>
@@ -8369,7 +8632,7 @@
               <a:buNone/>
             </a:pPr>
             <a:r>
-              <a:rPr lang="en-US" sz="750" dirty="0">
+              <a:rPr lang="en-US" sz="900" dirty="0">
                 <a:solidFill>
                   <a:srgbClr val="D4D4D4"/>
                 </a:solidFill>
@@ -8389,7 +8652,7 @@
               <a:buNone/>
             </a:pPr>
             <a:r>
-              <a:rPr lang="en-US" sz="750" dirty="0">
+              <a:rPr lang="en-US" sz="900" dirty="0">
                 <a:solidFill>
                   <a:srgbClr val="CE9178"/>
                 </a:solidFill>
@@ -8406,7 +8669,7 @@
               <a:buNone/>
             </a:pPr>
             <a:r>
-              <a:rPr lang="en-US" sz="750" dirty="0">
+              <a:rPr lang="en-US" sz="900" dirty="0">
                 <a:solidFill>
                   <a:srgbClr val="D4D4D4"/>
                 </a:solidFill>
@@ -8428,8 +8691,8 @@
         </p:nvSpPr>
         <p:spPr>
           <a:xfrm>
-            <a:off x="6876288" y="5998464"/>
-            <a:ext cx="4675327" cy="274320"/>
+            <a:off x="6541920" y="5998464"/>
+            <a:ext cx="5008600" cy="274320"/>
           </a:xfrm>
           <a:prstGeom prst="rect">
             <a:avLst/>
@@ -8531,7 +8794,7 @@
                 <a:ea typeface="Calibri" pitchFamily="34" charset="-122"/>
                 <a:cs typeface="Calibri" pitchFamily="34" charset="-120"/>
               </a:rPr>
-              <a:t>10</a:t>
+              <a:t>11</a:t>
             </a:r>
             <a:endParaRPr lang="en-US" sz="900" dirty="0"/>
           </a:p>
@@ -8545,7 +8808,7 @@
 </p:sld>
 </file>
 
-<file path=ppt/slides/slide12.xml><?xml version="1.0" encoding="utf-8"?>
+<file path=ppt/slides/slide13.xml><?xml version="1.0" encoding="utf-8"?>
 <p:sld xmlns:a="http://schemas.openxmlformats.org/drawingml/2006/main" xmlns:r="http://schemas.openxmlformats.org/officeDocument/2006/relationships" xmlns:p="http://schemas.openxmlformats.org/presentationml/2006/main">
   <p:cSld name="Slide 12">
     <p:bg>
@@ -9104,7 +9367,7 @@
 </p:sld>
 </file>
 
-<file path=ppt/slides/slide13.xml><?xml version="1.0" encoding="utf-8"?>
+<file path=ppt/slides/slide14.xml><?xml version="1.0" encoding="utf-8"?>
 <p:sld xmlns:a="http://schemas.openxmlformats.org/drawingml/2006/main" xmlns:r="http://schemas.openxmlformats.org/officeDocument/2006/relationships" xmlns:p="http://schemas.openxmlformats.org/presentationml/2006/main">
   <p:cSld name="Slide 13">
     <p:bg>
@@ -9429,6 +9692,10 @@
             <a:prstDash val="solid"/>
           </a:ln>
         </p:spPr>
+        <p:txBody>
+          <a:bodyPr/>
+          <a:p/>
+        </p:txBody>
       </p:sp>
       <p:sp>
         <p:nvSpPr>
@@ -9541,7 +9808,7 @@
                 <a:ea typeface="Calibri" pitchFamily="34" charset="-122"/>
                 <a:cs typeface="Calibri" pitchFamily="34" charset="-120"/>
               </a:rPr>
-              <a:t>문자열 한 줄 → 역할·변수가 있는 템플릿</a:t>
+              <a:t>문자열 한 줄 → 역할·변수가 있는 템플릿 — prompt_and_graph.py 로 실습</a:t>
             </a:r>
             <a:endParaRPr lang="en-US" sz="1450" dirty="0"/>
           </a:p>
@@ -9569,6 +9836,10 @@
             <a:prstDash val="solid"/>
           </a:ln>
         </p:spPr>
+        <p:txBody>
+          <a:bodyPr/>
+          <a:p/>
+        </p:txBody>
       </p:sp>
       <p:sp>
         <p:nvSpPr>
@@ -9594,6 +9865,10 @@
             <a:prstDash val="solid"/>
           </a:ln>
         </p:spPr>
+        <p:txBody>
+          <a:bodyPr/>
+          <a:p/>
+        </p:txBody>
       </p:sp>
       <p:sp>
         <p:nvSpPr>
@@ -9734,6 +10009,10 @@
             <a:prstDash val="solid"/>
           </a:ln>
         </p:spPr>
+        <p:txBody>
+          <a:bodyPr/>
+          <a:p/>
+        </p:txBody>
       </p:sp>
       <p:sp>
         <p:nvSpPr>
@@ -9759,6 +10038,10 @@
             <a:prstDash val="solid"/>
           </a:ln>
         </p:spPr>
+        <p:txBody>
+          <a:bodyPr/>
+          <a:p/>
+        </p:txBody>
       </p:sp>
       <p:sp>
         <p:nvSpPr>
@@ -9899,6 +10182,10 @@
             <a:prstDash val="solid"/>
           </a:ln>
         </p:spPr>
+        <p:txBody>
+          <a:bodyPr/>
+          <a:p/>
+        </p:txBody>
       </p:sp>
       <p:sp>
         <p:nvSpPr>
@@ -9924,6 +10211,10 @@
             <a:prstDash val="solid"/>
           </a:ln>
         </p:spPr>
+        <p:txBody>
+          <a:bodyPr/>
+          <a:p/>
+        </p:txBody>
       </p:sp>
       <p:sp>
         <p:nvSpPr>
@@ -11072,7 +11363,7 @@
                 <a:ea typeface="Calibri" pitchFamily="34" charset="-122"/>
                 <a:cs typeface="Calibri" pitchFamily="34" charset="-120"/>
               </a:rPr>
-              <a:t>코드 뜯어보기 ①</a:t>
+              <a:t>코드 뜯어보기 ① — prompt_and_graph.py</a:t>
             </a:r>
             <a:endParaRPr lang="en-US" sz="1200" dirty="0"/>
           </a:p>
@@ -11150,6 +11441,10 @@
             </a:outerShdw>
           </a:effectLst>
         </p:spPr>
+        <p:txBody>
+          <a:bodyPr/>
+          <a:p/>
+        </p:txBody>
       </p:sp>
       <p:sp>
         <p:nvSpPr>
@@ -11175,6 +11470,10 @@
             <a:prstDash val="solid"/>
           </a:ln>
         </p:spPr>
+        <p:txBody>
+          <a:bodyPr/>
+          <a:p/>
+        </p:txBody>
       </p:sp>
       <p:sp>
         <p:nvSpPr>
@@ -11200,6 +11499,10 @@
             <a:prstDash val="solid"/>
           </a:ln>
         </p:spPr>
+        <p:txBody>
+          <a:bodyPr/>
+          <a:p/>
+        </p:txBody>
       </p:sp>
       <p:sp>
         <p:nvSpPr>
@@ -11225,6 +11528,10 @@
             <a:prstDash val="solid"/>
           </a:ln>
         </p:spPr>
+        <p:txBody>
+          <a:bodyPr/>
+          <a:p/>
+        </p:txBody>
       </p:sp>
       <p:sp>
         <p:nvSpPr>
@@ -11762,6 +12069,10 @@
             <a:prstDash val="solid"/>
           </a:ln>
         </p:spPr>
+        <p:txBody>
+          <a:bodyPr/>
+          <a:p/>
+        </p:txBody>
       </p:sp>
       <p:sp>
         <p:nvSpPr>
@@ -11851,6 +12162,10 @@
             <a:prstDash val="solid"/>
           </a:ln>
         </p:spPr>
+        <p:txBody>
+          <a:bodyPr/>
+          <a:p/>
+        </p:txBody>
       </p:sp>
       <p:sp>
         <p:nvSpPr>
@@ -11989,6 +12304,40 @@
               <a:t>3</a:t>
             </a:r>
             <a:endParaRPr lang="en-US" sz="900" dirty="0"/>
+          </a:p>
+        </p:txBody>
+      </p:sp>
+      <p:sp>
+        <p:nvSpPr>
+          <p:cNvPr id="15" name="TextBox 14"/>
+          <p:cNvSpPr txBox="1"/>
+          <p:nvPr/>
+        </p:nvSpPr>
+        <p:spPr>
+          <a:xfrm>
+            <a:off x="7242048" y="5943600"/>
+            <a:ext cx="4309567" cy="274320"/>
+          </a:xfrm>
+          <a:prstGeom prst="rect">
+            <a:avLst/>
+          </a:prstGeom>
+          <a:noFill/>
+        </p:spPr>
+        <p:txBody>
+          <a:bodyPr wrap="square" lIns="0" rIns="0" tIns="0" bIns="0" anchor="ctr">
+            <a:spAutoFit/>
+          </a:bodyPr>
+          <a:lstStyle/>
+          <a:p>
+            <a:r>
+              <a:rPr sz="900">
+                <a:solidFill>
+                  <a:srgbClr val="5F7075"/>
+                </a:solidFill>
+                <a:latin typeface="Courier New"/>
+              </a:rPr>
+              <a:t>실행: python examples/prompt_and_graph.py --step 1</a:t>
+            </a:r>
           </a:p>
         </p:txBody>
       </p:sp>
@@ -13542,6 +13891,40 @@
           </a:p>
         </p:txBody>
       </p:sp>
+      <p:sp>
+        <p:nvSpPr>
+          <p:cNvPr id="15" name="TextBox 14"/>
+          <p:cNvSpPr txBox="1"/>
+          <p:nvPr/>
+        </p:nvSpPr>
+        <p:spPr>
+          <a:xfrm>
+            <a:off x="7242048" y="5943600"/>
+            <a:ext cx="4309567" cy="274320"/>
+          </a:xfrm>
+          <a:prstGeom prst="rect">
+            <a:avLst/>
+          </a:prstGeom>
+          <a:noFill/>
+        </p:spPr>
+        <p:txBody>
+          <a:bodyPr wrap="square" lIns="0" rIns="0" tIns="0" bIns="0" anchor="ctr">
+            <a:spAutoFit/>
+          </a:bodyPr>
+          <a:lstStyle/>
+          <a:p>
+            <a:r>
+              <a:rPr sz="900">
+                <a:solidFill>
+                  <a:srgbClr val="5F7075"/>
+                </a:solidFill>
+                <a:latin typeface="Courier New"/>
+              </a:rPr>
+              <a:t>실행: python examples/prompt_and_graph.py --step 2</a:t>
+            </a:r>
+          </a:p>
+        </p:txBody>
+      </p:sp>
     </p:spTree>
   </p:cSld>
   <p:clrMapOvr>
@@ -15534,6 +15917,40 @@
           </a:p>
         </p:txBody>
       </p:sp>
+      <p:sp>
+        <p:nvSpPr>
+          <p:cNvPr id="15" name="TextBox 14"/>
+          <p:cNvSpPr txBox="1"/>
+          <p:nvPr/>
+        </p:nvSpPr>
+        <p:spPr>
+          <a:xfrm>
+            <a:off x="7242048" y="5943600"/>
+            <a:ext cx="4309567" cy="274320"/>
+          </a:xfrm>
+          <a:prstGeom prst="rect">
+            <a:avLst/>
+          </a:prstGeom>
+          <a:noFill/>
+        </p:spPr>
+        <p:txBody>
+          <a:bodyPr wrap="square" lIns="0" rIns="0" tIns="0" bIns="0" anchor="ctr">
+            <a:spAutoFit/>
+          </a:bodyPr>
+          <a:lstStyle/>
+          <a:p>
+            <a:r>
+              <a:rPr sz="900">
+                <a:solidFill>
+                  <a:srgbClr val="5F7075"/>
+                </a:solidFill>
+                <a:latin typeface="Courier New"/>
+              </a:rPr>
+              <a:t>실행: python examples/prompt_and_graph.py --step 3</a:t>
+            </a:r>
+          </a:p>
+        </p:txBody>
+      </p:sp>
     </p:spTree>
   </p:cSld>
   <p:clrMapOvr>
@@ -18896,6 +19313,40 @@
               <a:t>7</a:t>
             </a:r>
             <a:endParaRPr lang="en-US" sz="900" dirty="0"/>
+          </a:p>
+        </p:txBody>
+      </p:sp>
+      <p:sp>
+        <p:nvSpPr>
+          <p:cNvPr id="15" name="TextBox 14"/>
+          <p:cNvSpPr txBox="1"/>
+          <p:nvPr/>
+        </p:nvSpPr>
+        <p:spPr>
+          <a:xfrm>
+            <a:off x="7242048" y="5943600"/>
+            <a:ext cx="4309567" cy="274320"/>
+          </a:xfrm>
+          <a:prstGeom prst="rect">
+            <a:avLst/>
+          </a:prstGeom>
+          <a:noFill/>
+        </p:spPr>
+        <p:txBody>
+          <a:bodyPr wrap="square" lIns="0" rIns="0" tIns="0" bIns="0" anchor="ctr">
+            <a:spAutoFit/>
+          </a:bodyPr>
+          <a:lstStyle/>
+          <a:p>
+            <a:r>
+              <a:rPr sz="900">
+                <a:solidFill>
+                  <a:srgbClr val="5F7075"/>
+                </a:solidFill>
+                <a:latin typeface="Courier New"/>
+              </a:rPr>
+              <a:t>실행: python examples/prompt_and_graph.py --step 4</a:t>
+            </a:r>
           </a:p>
         </p:txBody>
       </p:sp>

</xml_diff>